<commit_message>
Phase 3: dynamic N:N conferencing via SDP renegotiation
Drop the fixed E2EE_MAX_PEERS recvonly pool in favour of on-demand
renegotiation driven by the SFU's /signal endpoint.

- client.js: track percClientId/percRecvSlots; poll GET /signal and, when
  the conference grows, add recvonly transceivers and re-offer with the
  SFU-assigned client_id. Reset signaling state in endCall.
- native: webrtc_add_recv_transceivers + NAPI addRecvTransceivers; remove
  the fixed recvonly pool; lazy per-peer render windows.
- run-all.ps1: -SyntheticVideo switch and per-component env; default
  alice/bob/carol three-client launch.
- config.json: mark conference.maxParticipants legacy/unused.
- docs: README, architecture (§12), plan updated for dynamic renegotiation;
  regenerated E2EE-Architecture.pptx (Phase 3 status, N:N slide, roadmap).
- bump str0m submodule pointer.
</commit_message>
<xml_diff>
--- a/docs/E2EE-Architecture.pptx
+++ b/docs/E2EE-Architecture.pptx
@@ -20,6 +20,7 @@
     <p:sldId id="268" r:id="rId19"/>
     <p:sldId id="269" r:id="rId20"/>
     <p:sldId id="270" r:id="rId21"/>
+    <p:sldId id="271" r:id="rId22"/>
   </p:sldIdLst>
   <p:sldSz cx="12191695" cy="6858000" type="screen4x3"/>
   <p:notesSz cx="6858000" cy="9144000"/>
@@ -5200,7 +5201,7 @@
                 </a:solidFill>
                 <a:latin typeface="Segoe UI"/>
               </a:rPr>
-              <a:t>SECURITY</a:t>
+              <a:t>PHASE 3</a:t>
             </a:r>
           </a:p>
         </p:txBody>
@@ -5235,7 +5236,7 @@
                 </a:solidFill>
                 <a:latin typeface="Segoe UI"/>
               </a:rPr>
-              <a:t>What the SFU can — and cannot — see</a:t>
+              <a:t>Multi-party (N:N) — dynamic SDP renegotiation</a:t>
             </a:r>
           </a:p>
         </p:txBody>
@@ -5248,14 +5249,215 @@
         </p:nvSpPr>
         <p:spPr>
           <a:xfrm>
-            <a:off x="640080" y="1737360"/>
-            <a:ext cx="5303520" cy="3291840"/>
+            <a:off x="640080" y="1554480"/>
+            <a:ext cx="2286000" cy="914400"/>
           </a:xfrm>
           <a:prstGeom prst="roundRect">
             <a:avLst/>
           </a:prstGeom>
           <a:solidFill>
-            <a:srgbClr val="1B2A4A"/>
+            <a:srgbClr val="2E5C9E"/>
+          </a:solidFill>
+          <a:ln w="15875">
+            <a:solidFill>
+              <a:srgbClr val="4C9AFF"/>
+            </a:solidFill>
+          </a:ln>
+          <a:effectLst/>
+        </p:spPr>
+        <p:style>
+          <a:lnRef idx="1">
+            <a:schemeClr val="accent1"/>
+          </a:lnRef>
+          <a:fillRef idx="3">
+            <a:schemeClr val="accent1"/>
+          </a:fillRef>
+          <a:effectRef idx="2">
+            <a:schemeClr val="accent1"/>
+          </a:effectRef>
+          <a:fontRef idx="minor">
+            <a:schemeClr val="lt1"/>
+          </a:fontRef>
+        </p:style>
+        <p:txBody>
+          <a:bodyPr rtlCol="0" anchor="ctr" wrap="square" lIns="73152" rIns="73152" tIns="36576" bIns="36576"/>
+          <a:lstStyle/>
+          <a:p>
+            <a:pPr algn="ctr"/>
+            <a:r>
+              <a:rPr sz="1400" b="1">
+                <a:solidFill>
+                  <a:srgbClr val="F5F8FF"/>
+                </a:solidFill>
+                <a:latin typeface="Segoe UI"/>
+              </a:rPr>
+              <a:t>alice joins</a:t>
+            </a:r>
+          </a:p>
+          <a:p>
+            <a:pPr algn="ctr"/>
+            <a:r>
+              <a:rPr sz="1400" b="1">
+                <a:solidFill>
+                  <a:srgbClr val="F5F8FF"/>
+                </a:solidFill>
+                <a:latin typeface="Segoe UI"/>
+              </a:rPr>
+              <a:t>offers own A+V</a:t>
+            </a:r>
+          </a:p>
+        </p:txBody>
+      </p:sp>
+      <p:sp>
+        <p:nvSpPr>
+          <p:cNvPr id="7" name="Rounded Rectangle 6"/>
+          <p:cNvSpPr/>
+          <p:nvPr/>
+        </p:nvSpPr>
+        <p:spPr>
+          <a:xfrm>
+            <a:off x="3200400" y="1554480"/>
+            <a:ext cx="2286000" cy="914400"/>
+          </a:xfrm>
+          <a:prstGeom prst="roundRect">
+            <a:avLst/>
+          </a:prstGeom>
+          <a:solidFill>
+            <a:srgbClr val="2E5C9E"/>
+          </a:solidFill>
+          <a:ln w="15875">
+            <a:solidFill>
+              <a:srgbClr val="4C9AFF"/>
+            </a:solidFill>
+          </a:ln>
+          <a:effectLst/>
+        </p:spPr>
+        <p:style>
+          <a:lnRef idx="1">
+            <a:schemeClr val="accent1"/>
+          </a:lnRef>
+          <a:fillRef idx="3">
+            <a:schemeClr val="accent1"/>
+          </a:fillRef>
+          <a:effectRef idx="2">
+            <a:schemeClr val="accent1"/>
+          </a:effectRef>
+          <a:fontRef idx="minor">
+            <a:schemeClr val="lt1"/>
+          </a:fontRef>
+        </p:style>
+        <p:txBody>
+          <a:bodyPr rtlCol="0" anchor="ctr" wrap="square" lIns="73152" rIns="73152" tIns="36576" bIns="36576"/>
+          <a:lstStyle/>
+          <a:p>
+            <a:pPr algn="ctr"/>
+            <a:r>
+              <a:rPr sz="1400" b="1">
+                <a:solidFill>
+                  <a:srgbClr val="F5F8FF"/>
+                </a:solidFill>
+                <a:latin typeface="Segoe UI"/>
+              </a:rPr>
+              <a:t>bob joins</a:t>
+            </a:r>
+          </a:p>
+          <a:p>
+            <a:pPr algn="ctr"/>
+            <a:r>
+              <a:rPr sz="1400" b="1">
+                <a:solidFill>
+                  <a:srgbClr val="F5F8FF"/>
+                </a:solidFill>
+                <a:latin typeface="Segoe UI"/>
+              </a:rPr>
+              <a:t>1:1 — no reneg</a:t>
+            </a:r>
+          </a:p>
+        </p:txBody>
+      </p:sp>
+      <p:sp>
+        <p:nvSpPr>
+          <p:cNvPr id="8" name="Rounded Rectangle 7"/>
+          <p:cNvSpPr/>
+          <p:nvPr/>
+        </p:nvSpPr>
+        <p:spPr>
+          <a:xfrm>
+            <a:off x="5760720" y="1554480"/>
+            <a:ext cx="2286000" cy="914400"/>
+          </a:xfrm>
+          <a:prstGeom prst="roundRect">
+            <a:avLst/>
+          </a:prstGeom>
+          <a:solidFill>
+            <a:srgbClr val="6B478F"/>
+          </a:solidFill>
+          <a:ln w="15875">
+            <a:solidFill>
+              <a:srgbClr val="4C9AFF"/>
+            </a:solidFill>
+          </a:ln>
+          <a:effectLst/>
+        </p:spPr>
+        <p:style>
+          <a:lnRef idx="1">
+            <a:schemeClr val="accent1"/>
+          </a:lnRef>
+          <a:fillRef idx="3">
+            <a:schemeClr val="accent1"/>
+          </a:fillRef>
+          <a:effectRef idx="2">
+            <a:schemeClr val="accent1"/>
+          </a:effectRef>
+          <a:fontRef idx="minor">
+            <a:schemeClr val="lt1"/>
+          </a:fontRef>
+        </p:style>
+        <p:txBody>
+          <a:bodyPr rtlCol="0" anchor="ctr" wrap="square" lIns="73152" rIns="73152" tIns="36576" bIns="36576"/>
+          <a:lstStyle/>
+          <a:p>
+            <a:pPr algn="ctr"/>
+            <a:r>
+              <a:rPr sz="1400" b="1">
+                <a:solidFill>
+                  <a:srgbClr val="F5F8FF"/>
+                </a:solidFill>
+                <a:latin typeface="Segoe UI"/>
+              </a:rPr>
+              <a:t>carol joins</a:t>
+            </a:r>
+          </a:p>
+          <a:p>
+            <a:pPr algn="ctr"/>
+            <a:r>
+              <a:rPr sz="1400" b="1">
+                <a:solidFill>
+                  <a:srgbClr val="F5F8FF"/>
+                </a:solidFill>
+                <a:latin typeface="Segoe UI"/>
+              </a:rPr>
+              <a:t>SFU recomputes</a:t>
+            </a:r>
+          </a:p>
+        </p:txBody>
+      </p:sp>
+      <p:sp>
+        <p:nvSpPr>
+          <p:cNvPr id="9" name="Rounded Rectangle 8"/>
+          <p:cNvSpPr/>
+          <p:nvPr/>
+        </p:nvSpPr>
+        <p:spPr>
+          <a:xfrm>
+            <a:off x="8321040" y="1554480"/>
+            <a:ext cx="3200400" cy="914400"/>
+          </a:xfrm>
+          <a:prstGeom prst="roundRect">
+            <a:avLst/>
+          </a:prstGeom>
+          <a:solidFill>
+            <a:srgbClr val="6B478F"/>
           </a:solidFill>
           <a:ln w="15875">
             <a:solidFill>
@@ -5282,204 +5484,271 @@
           <a:bodyPr rtlCol="0" anchor="ctr" wrap="square" lIns="73152" rIns="73152" tIns="36576" bIns="36576"/>
           <a:lstStyle/>
           <a:p>
-            <a:pPr algn="l"/>
-            <a:r>
-              <a:rPr sz="1600" b="0">
-                <a:solidFill>
-                  <a:srgbClr val="F5F8FF"/>
-                </a:solidFill>
-                <a:latin typeface="Segoe UI"/>
-              </a:rPr>
-              <a:t>VISIBLE</a:t>
-            </a:r>
-          </a:p>
-          <a:p>
-            <a:pPr algn="l"/>
-            <a:r>
-              <a:rPr sz="1600" b="0">
-                <a:solidFill>
-                  <a:srgbClr val="F5F8FF"/>
-                </a:solidFill>
-                <a:latin typeface="Segoe UI"/>
-              </a:rPr>
-              <a:t/>
-            </a:r>
-          </a:p>
-          <a:p>
-            <a:pPr algn="l"/>
-            <a:r>
-              <a:rPr sz="1600" b="0">
-                <a:solidFill>
-                  <a:srgbClr val="F5F8FF"/>
-                </a:solidFill>
-                <a:latin typeface="Segoe UI"/>
-              </a:rPr>
-              <a:t>RTP headers (SSRC/PT/seq/ts)</a:t>
-            </a:r>
-          </a:p>
-          <a:p>
-            <a:pPr algn="l"/>
-            <a:r>
-              <a:rPr sz="1600" b="0">
-                <a:solidFill>
-                  <a:srgbClr val="F5F8FF"/>
-                </a:solidFill>
-                <a:latin typeface="Segoe UI"/>
-              </a:rPr>
-              <a:t>HBH SRTP for its own legs</a:t>
-            </a:r>
-          </a:p>
-          <a:p>
-            <a:pPr algn="l"/>
-            <a:r>
-              <a:rPr sz="1600" b="0">
-                <a:solidFill>
-                  <a:srgbClr val="F5F8FF"/>
-                </a:solidFill>
-                <a:latin typeface="Segoe UI"/>
-              </a:rPr>
-              <a:t>1-byte VP8 key/delta marker</a:t>
-            </a:r>
-          </a:p>
-          <a:p>
-            <a:pPr algn="l"/>
-            <a:r>
-              <a:rPr sz="1600" b="0">
-                <a:solidFill>
-                  <a:srgbClr val="F5F8FF"/>
-                </a:solidFill>
-                <a:latin typeface="Segoe UI"/>
-              </a:rPr>
-              <a:t>Packet sizes &amp; timing</a:t>
-            </a:r>
-          </a:p>
-        </p:txBody>
-      </p:sp>
-      <p:sp>
-        <p:nvSpPr>
-          <p:cNvPr id="7" name="Rounded Rectangle 6"/>
-          <p:cNvSpPr/>
-          <p:nvPr/>
-        </p:nvSpPr>
-        <p:spPr>
-          <a:xfrm>
-            <a:off x="6217920" y="1737360"/>
-            <a:ext cx="5303520" cy="3291840"/>
-          </a:xfrm>
-          <a:prstGeom prst="roundRect">
-            <a:avLst/>
-          </a:prstGeom>
-          <a:solidFill>
-            <a:srgbClr val="1B2A4A"/>
-          </a:solidFill>
-          <a:ln w="15875">
+            <a:pPr algn="ctr"/>
+            <a:r>
+              <a:rPr sz="1400" b="1">
+                <a:solidFill>
+                  <a:srgbClr val="F5F8FF"/>
+                </a:solidFill>
+                <a:latin typeface="Segoe UI"/>
+              </a:rPr>
+              <a:t>all re-offer +1 slot</a:t>
+            </a:r>
+          </a:p>
+          <a:p>
+            <a:pPr algn="ctr"/>
+            <a:r>
+              <a:rPr sz="1400" b="1">
+                <a:solidFill>
+                  <a:srgbClr val="F5F8FF"/>
+                </a:solidFill>
+                <a:latin typeface="Segoe UI"/>
+              </a:rPr>
+              <a:t>3-way fan-out</a:t>
+            </a:r>
+          </a:p>
+        </p:txBody>
+      </p:sp>
+      <p:cxnSp>
+        <p:nvCxnSpPr>
+          <p:cNvPr id="10" name="Connector 9"/>
+          <p:cNvCxnSpPr/>
+          <p:nvPr/>
+        </p:nvCxnSpPr>
+        <p:spPr>
+          <a:xfrm>
+            <a:off x="2926080" y="2011680"/>
+            <a:ext cx="274320" cy="0"/>
+          </a:xfrm>
+          <a:prstGeom prst="line">
+            <a:avLst/>
+          </a:prstGeom>
+          <a:ln w="19050">
             <a:solidFill>
-              <a:srgbClr val="35D09B"/>
+              <a:srgbClr val="A9B8D6"/>
             </a:solidFill>
+            <a:tailEnd type="triangle" w="med" len="med"/>
           </a:ln>
           <a:effectLst/>
         </p:spPr>
         <p:style>
-          <a:lnRef idx="1">
+          <a:lnRef idx="2">
             <a:schemeClr val="accent1"/>
           </a:lnRef>
-          <a:fillRef idx="3">
+          <a:fillRef idx="0">
             <a:schemeClr val="accent1"/>
           </a:fillRef>
-          <a:effectRef idx="2">
+          <a:effectRef idx="1">
             <a:schemeClr val="accent1"/>
           </a:effectRef>
           <a:fontRef idx="minor">
-            <a:schemeClr val="lt1"/>
+            <a:schemeClr val="tx1"/>
           </a:fontRef>
         </p:style>
-        <p:txBody>
-          <a:bodyPr rtlCol="0" anchor="ctr" wrap="square" lIns="73152" rIns="73152" tIns="36576" bIns="36576"/>
-          <a:lstStyle/>
-          <a:p>
-            <a:pPr algn="l"/>
-            <a:r>
-              <a:rPr sz="1600" b="0">
-                <a:solidFill>
-                  <a:srgbClr val="F5F8FF"/>
-                </a:solidFill>
-                <a:latin typeface="Segoe UI"/>
-              </a:rPr>
-              <a:t>HIDDEN</a:t>
-            </a:r>
-          </a:p>
-          <a:p>
-            <a:pPr algn="l"/>
-            <a:r>
-              <a:rPr sz="1600" b="0">
-                <a:solidFill>
-                  <a:srgbClr val="F5F8FF"/>
-                </a:solidFill>
-                <a:latin typeface="Segoe UI"/>
-              </a:rPr>
-              <a:t/>
-            </a:r>
-          </a:p>
-          <a:p>
-            <a:pPr algn="l"/>
-            <a:r>
-              <a:rPr sz="1600" b="0">
-                <a:solidFill>
-                  <a:srgbClr val="F5F8FF"/>
-                </a:solidFill>
-                <a:latin typeface="Segoe UI"/>
-              </a:rPr>
-              <a:t>E2E media payload (inner GCM)</a:t>
-            </a:r>
-          </a:p>
-          <a:p>
-            <a:pPr algn="l"/>
-            <a:r>
-              <a:rPr sz="1600" b="0">
-                <a:solidFill>
-                  <a:srgbClr val="F5F8FF"/>
-                </a:solidFill>
-                <a:latin typeface="Segoe UI"/>
-              </a:rPr>
-              <a:t>The E2E key (KD + clients only)</a:t>
-            </a:r>
-          </a:p>
-          <a:p>
-            <a:pPr algn="l"/>
-            <a:r>
-              <a:rPr sz="1600" b="0">
-                <a:solidFill>
-                  <a:srgbClr val="F5F8FF"/>
-                </a:solidFill>
-                <a:latin typeface="Segoe UI"/>
-              </a:rPr>
-              <a:t>Decoded media / codec bitstream</a:t>
-            </a:r>
-          </a:p>
-          <a:p>
-            <a:pPr algn="l"/>
-            <a:r>
-              <a:rPr sz="1600" b="0">
-                <a:solidFill>
-                  <a:srgbClr val="F5F8FF"/>
-                </a:solidFill>
-                <a:latin typeface="Segoe UI"/>
-              </a:rPr>
-              <a:t>Inner header extensions</a:t>
-            </a:r>
-          </a:p>
-        </p:txBody>
-      </p:sp>
-      <p:sp>
-        <p:nvSpPr>
-          <p:cNvPr id="8" name="TextBox 7"/>
+      </p:cxnSp>
+      <p:cxnSp>
+        <p:nvCxnSpPr>
+          <p:cNvPr id="11" name="Connector 10"/>
+          <p:cNvCxnSpPr/>
+          <p:nvPr/>
+        </p:nvCxnSpPr>
+        <p:spPr>
+          <a:xfrm>
+            <a:off x="5486400" y="2011680"/>
+            <a:ext cx="274320" cy="0"/>
+          </a:xfrm>
+          <a:prstGeom prst="line">
+            <a:avLst/>
+          </a:prstGeom>
+          <a:ln w="19050">
+            <a:solidFill>
+              <a:srgbClr val="A9B8D6"/>
+            </a:solidFill>
+            <a:tailEnd type="triangle" w="med" len="med"/>
+          </a:ln>
+          <a:effectLst/>
+        </p:spPr>
+        <p:style>
+          <a:lnRef idx="2">
+            <a:schemeClr val="accent1"/>
+          </a:lnRef>
+          <a:fillRef idx="0">
+            <a:schemeClr val="accent1"/>
+          </a:fillRef>
+          <a:effectRef idx="1">
+            <a:schemeClr val="accent1"/>
+          </a:effectRef>
+          <a:fontRef idx="minor">
+            <a:schemeClr val="tx1"/>
+          </a:fontRef>
+        </p:style>
+      </p:cxnSp>
+      <p:cxnSp>
+        <p:nvCxnSpPr>
+          <p:cNvPr id="12" name="Connector 11"/>
+          <p:cNvCxnSpPr/>
+          <p:nvPr/>
+        </p:nvCxnSpPr>
+        <p:spPr>
+          <a:xfrm>
+            <a:off x="8046720" y="2011680"/>
+            <a:ext cx="274320" cy="0"/>
+          </a:xfrm>
+          <a:prstGeom prst="line">
+            <a:avLst/>
+          </a:prstGeom>
+          <a:ln w="19050">
+            <a:solidFill>
+              <a:srgbClr val="A9B8D6"/>
+            </a:solidFill>
+            <a:tailEnd type="triangle" w="med" len="med"/>
+          </a:ln>
+          <a:effectLst/>
+        </p:spPr>
+        <p:style>
+          <a:lnRef idx="2">
+            <a:schemeClr val="accent1"/>
+          </a:lnRef>
+          <a:fillRef idx="0">
+            <a:schemeClr val="accent1"/>
+          </a:fillRef>
+          <a:effectRef idx="1">
+            <a:schemeClr val="accent1"/>
+          </a:effectRef>
+          <a:fontRef idx="minor">
+            <a:schemeClr val="tx1"/>
+          </a:fontRef>
+        </p:style>
+      </p:cxnSp>
+      <p:sp>
+        <p:nvSpPr>
+          <p:cNvPr id="13" name="TextBox 12"/>
           <p:cNvSpPr txBox="1"/>
           <p:nvPr/>
         </p:nvSpPr>
         <p:spPr>
           <a:xfrm>
-            <a:off x="640080" y="5303520"/>
-            <a:ext cx="10881360" cy="640080"/>
+            <a:off x="640080" y="2834640"/>
+            <a:ext cx="10789920" cy="4572000"/>
+          </a:xfrm>
+          <a:prstGeom prst="rect">
+            <a:avLst/>
+          </a:prstGeom>
+          <a:noFill/>
+        </p:spPr>
+        <p:txBody>
+          <a:bodyPr wrap="square">
+            <a:spAutoFit/>
+          </a:bodyPr>
+          <a:lstStyle/>
+          <a:p>
+            <a:pPr>
+              <a:spcAft>
+                <a:spcPts val="1152"/>
+              </a:spcAft>
+            </a:pPr>
+            <a:r>
+              <a:rPr sz="1800">
+                <a:solidFill>
+                  <a:srgbClr val="F5F8FF"/>
+                </a:solidFill>
+                <a:latin typeface="Segoe UI"/>
+              </a:rPr>
+              <a:t>• No fixed transceiver pool, no maxParticipants cap — the client is always the offerer.</a:t>
+            </a:r>
+          </a:p>
+          <a:p>
+            <a:pPr>
+              <a:spcAft>
+                <a:spcPts val="1152"/>
+              </a:spcAft>
+            </a:pPr>
+            <a:r>
+              <a:rPr sz="1800">
+                <a:solidFill>
+                  <a:srgbClr val="F5F8FF"/>
+                </a:solidFill>
+                <a:latin typeface="Segoe UI"/>
+              </a:rPr>
+              <a:t>• Initial offer carries only the client's own sendrecv audio+video, so 1:1 needs zero reneg.</a:t>
+            </a:r>
+          </a:p>
+          <a:p>
+            <a:pPr>
+              <a:spcAft>
+                <a:spcPts val="1152"/>
+              </a:spcAft>
+            </a:pPr>
+            <a:r>
+              <a:rPr sz="1800">
+                <a:solidFill>
+                  <a:srgbClr val="F5F8FF"/>
+                </a:solidFill>
+                <a:latin typeface="Segoe UI"/>
+              </a:rPr>
+              <a:t>• On membership change the SFU computes recv_slots = participants − 1 per kind, per client.</a:t>
+            </a:r>
+          </a:p>
+          <a:p>
+            <a:pPr>
+              <a:spcAft>
+                <a:spcPts val="1152"/>
+              </a:spcAft>
+            </a:pPr>
+            <a:r>
+              <a:rPr sz="1800">
+                <a:solidFill>
+                  <a:srgbClr val="F5F8FF"/>
+                </a:solidFill>
+                <a:latin typeface="Segoe UI"/>
+              </a:rPr>
+              <a:t>• Client polls GET /signal?client_id=N; when slots grow it adds recvonly transceivers and re-offers.</a:t>
+            </a:r>
+          </a:p>
+          <a:p>
+            <a:pPr>
+              <a:spcAft>
+                <a:spcPts val="1152"/>
+              </a:spcAft>
+            </a:pPr>
+            <a:r>
+              <a:rPr sz="1800">
+                <a:solidFill>
+                  <a:srgbClr val="F5F8FF"/>
+                </a:solidFill>
+                <a:latin typeface="Segoe UI"/>
+              </a:rPr>
+              <a:t>• POST /offer is relayed into the SFU run loop (request/reply channel) so accept_offer runs on the live Rtc.</a:t>
+            </a:r>
+          </a:p>
+          <a:p>
+            <a:pPr>
+              <a:spcAft>
+                <a:spcPts val="1152"/>
+              </a:spcAft>
+            </a:pPr>
+            <a:r>
+              <a:rPr sz="1800">
+                <a:solidFill>
+                  <a:srgbClr val="F5F8FF"/>
+                </a:solidFill>
+                <a:latin typeface="Segoe UI"/>
+              </a:rPr>
+              <a:t>• assign_slot pins each origin to a distinct m-line → every remote peer renders in its own window.</a:t>
+            </a:r>
+          </a:p>
+        </p:txBody>
+      </p:sp>
+      <p:sp>
+        <p:nvSpPr>
+          <p:cNvPr id="14" name="TextBox 13"/>
+          <p:cNvSpPr txBox="1"/>
+          <p:nvPr/>
+        </p:nvSpPr>
+        <p:spPr>
+          <a:xfrm>
+            <a:off x="548640" y="6446520"/>
+            <a:ext cx="7315200" cy="320040"/>
           </a:xfrm>
           <a:prstGeom prst="rect">
             <a:avLst/>
@@ -5492,49 +5761,14 @@
           </a:bodyPr>
           <a:lstStyle/>
           <a:p>
-            <a:pPr algn="ctr"/>
-            <a:r>
-              <a:rPr sz="1500" b="0">
+            <a:pPr algn="l"/>
+            <a:r>
+              <a:rPr sz="1000" b="0">
                 <a:solidFill>
                   <a:srgbClr val="A9B8D6"/>
                 </a:solidFill>
                 <a:latin typeface="Segoe UI"/>
               </a:rPr>
-              <a:t>Server compromise leaks routing metadata only — never the media content.</a:t>
-            </a:r>
-          </a:p>
-        </p:txBody>
-      </p:sp>
-      <p:sp>
-        <p:nvSpPr>
-          <p:cNvPr id="9" name="TextBox 8"/>
-          <p:cNvSpPr txBox="1"/>
-          <p:nvPr/>
-        </p:nvSpPr>
-        <p:spPr>
-          <a:xfrm>
-            <a:off x="548640" y="6446520"/>
-            <a:ext cx="7315200" cy="320040"/>
-          </a:xfrm>
-          <a:prstGeom prst="rect">
-            <a:avLst/>
-          </a:prstGeom>
-          <a:noFill/>
-        </p:spPr>
-        <p:txBody>
-          <a:bodyPr wrap="square" anchor="t">
-            <a:spAutoFit/>
-          </a:bodyPr>
-          <a:lstStyle/>
-          <a:p>
-            <a:pPr algn="l"/>
-            <a:r>
-              <a:rPr sz="1000" b="0">
-                <a:solidFill>
-                  <a:srgbClr val="A9B8D6"/>
-                </a:solidFill>
-                <a:latin typeface="Segoe UI"/>
-              </a:rPr>
               <a:t>E2EE WebRTC — Zero-Trust SFU (str0m + PERC)</a:t>
             </a:r>
           </a:p>
@@ -5542,7 +5776,7 @@
       </p:sp>
       <p:sp>
         <p:nvSpPr>
-          <p:cNvPr id="10" name="TextBox 9"/>
+          <p:cNvPr id="15" name="TextBox 14"/>
           <p:cNvSpPr txBox="1"/>
           <p:nvPr/>
         </p:nvSpPr>
@@ -5711,7 +5945,7 @@
                 </a:solidFill>
                 <a:latin typeface="Segoe UI"/>
               </a:rPr>
-              <a:t>OPERATIONS</a:t>
+              <a:t>SECURITY</a:t>
             </a:r>
           </a:p>
         </p:txBody>
@@ -5746,7 +5980,7 @@
                 </a:solidFill>
                 <a:latin typeface="Segoe UI"/>
               </a:rPr>
-              <a:t>Unified configuration system</a:t>
+              <a:t>What the SFU can — and cannot — see</a:t>
             </a:r>
           </a:p>
         </p:txBody>
@@ -5759,8 +5993,8 @@
         </p:nvSpPr>
         <p:spPr>
           <a:xfrm>
-            <a:off x="640080" y="1645920"/>
-            <a:ext cx="3291840" cy="1005840"/>
+            <a:off x="640080" y="1737360"/>
+            <a:ext cx="5303520" cy="3291840"/>
           </a:xfrm>
           <a:prstGeom prst="roundRect">
             <a:avLst/>
@@ -5770,7 +6004,7 @@
           </a:solidFill>
           <a:ln w="15875">
             <a:solidFill>
-              <a:srgbClr val="4C9AFF"/>
+              <a:srgbClr val="F2B14C"/>
             </a:solidFill>
           </a:ln>
           <a:effectLst/>
@@ -5793,27 +6027,75 @@
           <a:bodyPr rtlCol="0" anchor="ctr" wrap="square" lIns="73152" rIns="73152" tIns="36576" bIns="36576"/>
           <a:lstStyle/>
           <a:p>
-            <a:pPr algn="ctr"/>
-            <a:r>
-              <a:rPr sz="1400" b="1">
-                <a:solidFill>
-                  <a:srgbClr val="F5F8FF"/>
-                </a:solidFill>
-                <a:latin typeface="Segoe UI"/>
-              </a:rPr>
-              <a:t>config.json (JSONC)</a:t>
-            </a:r>
-          </a:p>
-          <a:p>
-            <a:pPr algn="ctr"/>
-            <a:r>
-              <a:rPr sz="1400" b="1">
-                <a:solidFill>
-                  <a:srgbClr val="F5F8FF"/>
-                </a:solidFill>
-                <a:latin typeface="Segoe UI"/>
-              </a:rPr>
-              <a:t>sectioned OR flat</a:t>
+            <a:pPr algn="l"/>
+            <a:r>
+              <a:rPr sz="1600" b="0">
+                <a:solidFill>
+                  <a:srgbClr val="F5F8FF"/>
+                </a:solidFill>
+                <a:latin typeface="Segoe UI"/>
+              </a:rPr>
+              <a:t>VISIBLE</a:t>
+            </a:r>
+          </a:p>
+          <a:p>
+            <a:pPr algn="l"/>
+            <a:r>
+              <a:rPr sz="1600" b="0">
+                <a:solidFill>
+                  <a:srgbClr val="F5F8FF"/>
+                </a:solidFill>
+                <a:latin typeface="Segoe UI"/>
+              </a:rPr>
+              <a:t/>
+            </a:r>
+          </a:p>
+          <a:p>
+            <a:pPr algn="l"/>
+            <a:r>
+              <a:rPr sz="1600" b="0">
+                <a:solidFill>
+                  <a:srgbClr val="F5F8FF"/>
+                </a:solidFill>
+                <a:latin typeface="Segoe UI"/>
+              </a:rPr>
+              <a:t>RTP headers (SSRC/PT/seq/ts)</a:t>
+            </a:r>
+          </a:p>
+          <a:p>
+            <a:pPr algn="l"/>
+            <a:r>
+              <a:rPr sz="1600" b="0">
+                <a:solidFill>
+                  <a:srgbClr val="F5F8FF"/>
+                </a:solidFill>
+                <a:latin typeface="Segoe UI"/>
+              </a:rPr>
+              <a:t>HBH SRTP for its own legs</a:t>
+            </a:r>
+          </a:p>
+          <a:p>
+            <a:pPr algn="l"/>
+            <a:r>
+              <a:rPr sz="1600" b="0">
+                <a:solidFill>
+                  <a:srgbClr val="F5F8FF"/>
+                </a:solidFill>
+                <a:latin typeface="Segoe UI"/>
+              </a:rPr>
+              <a:t>1-byte VP8 key/delta marker</a:t>
+            </a:r>
+          </a:p>
+          <a:p>
+            <a:pPr algn="l"/>
+            <a:r>
+              <a:rPr sz="1600" b="0">
+                <a:solidFill>
+                  <a:srgbClr val="F5F8FF"/>
+                </a:solidFill>
+                <a:latin typeface="Segoe UI"/>
+              </a:rPr>
+              <a:t>Packet sizes &amp; timing</a:t>
             </a:r>
           </a:p>
         </p:txBody>
@@ -5826,113 +6108,8 @@
         </p:nvSpPr>
         <p:spPr>
           <a:xfrm>
-            <a:off x="4206240" y="1645920"/>
-            <a:ext cx="2286000" cy="1005840"/>
-          </a:xfrm>
-          <a:prstGeom prst="roundRect">
-            <a:avLst/>
-          </a:prstGeom>
-          <a:solidFill>
-            <a:srgbClr val="1B2A4A"/>
-          </a:solidFill>
-          <a:ln w="15875">
-            <a:solidFill>
-              <a:srgbClr val="4C9AFF"/>
-            </a:solidFill>
-          </a:ln>
-          <a:effectLst/>
-        </p:spPr>
-        <p:style>
-          <a:lnRef idx="1">
-            <a:schemeClr val="accent1"/>
-          </a:lnRef>
-          <a:fillRef idx="3">
-            <a:schemeClr val="accent1"/>
-          </a:fillRef>
-          <a:effectRef idx="2">
-            <a:schemeClr val="accent1"/>
-          </a:effectRef>
-          <a:fontRef idx="minor">
-            <a:schemeClr val="lt1"/>
-          </a:fontRef>
-        </p:style>
-        <p:txBody>
-          <a:bodyPr rtlCol="0" anchor="ctr" wrap="square" lIns="73152" rIns="73152" tIns="36576" bIns="36576"/>
-          <a:lstStyle/>
-          <a:p>
-            <a:pPr algn="ctr"/>
-            <a:r>
-              <a:rPr sz="1300" b="0">
-                <a:solidFill>
-                  <a:srgbClr val="F5F8FF"/>
-                </a:solidFill>
-                <a:latin typeface="Segoe UI"/>
-              </a:rPr>
-              <a:t>sfu</a:t>
-            </a:r>
-          </a:p>
-          <a:p>
-            <a:pPr algn="ctr"/>
-            <a:r>
-              <a:rPr sz="1300" b="0">
-                <a:solidFill>
-                  <a:srgbClr val="F5F8FF"/>
-                </a:solidFill>
-                <a:latin typeface="Segoe UI"/>
-              </a:rPr>
-              <a:t>+ shared
-logging/stats/diag</a:t>
-            </a:r>
-          </a:p>
-        </p:txBody>
-      </p:sp>
-      <p:cxnSp>
-        <p:nvCxnSpPr>
-          <p:cNvPr id="8" name="Connector 7"/>
-          <p:cNvCxnSpPr/>
-          <p:nvPr/>
-        </p:nvCxnSpPr>
-        <p:spPr>
-          <a:xfrm>
-            <a:off x="3931920" y="2148840"/>
-            <a:ext cx="274320" cy="0"/>
-          </a:xfrm>
-          <a:prstGeom prst="line">
-            <a:avLst/>
-          </a:prstGeom>
-          <a:ln w="19050">
-            <a:solidFill>
-              <a:srgbClr val="A9B8D6"/>
-            </a:solidFill>
-            <a:tailEnd type="triangle" w="med" len="med"/>
-          </a:ln>
-          <a:effectLst/>
-        </p:spPr>
-        <p:style>
-          <a:lnRef idx="2">
-            <a:schemeClr val="accent1"/>
-          </a:lnRef>
-          <a:fillRef idx="0">
-            <a:schemeClr val="accent1"/>
-          </a:fillRef>
-          <a:effectRef idx="1">
-            <a:schemeClr val="accent1"/>
-          </a:effectRef>
-          <a:fontRef idx="minor">
-            <a:schemeClr val="tx1"/>
-          </a:fontRef>
-        </p:style>
-      </p:cxnSp>
-      <p:sp>
-        <p:nvSpPr>
-          <p:cNvPr id="9" name="Rounded Rectangle 8"/>
-          <p:cNvSpPr/>
-          <p:nvPr/>
-        </p:nvSpPr>
-        <p:spPr>
-          <a:xfrm>
-            <a:off x="6675120" y="1645920"/>
-            <a:ext cx="2286000" cy="1005840"/>
+            <a:off x="6217920" y="1737360"/>
+            <a:ext cx="5303520" cy="3291840"/>
           </a:xfrm>
           <a:prstGeom prst="roundRect">
             <a:avLst/>
@@ -5965,303 +6142,89 @@
           <a:bodyPr rtlCol="0" anchor="ctr" wrap="square" lIns="73152" rIns="73152" tIns="36576" bIns="36576"/>
           <a:lstStyle/>
           <a:p>
-            <a:pPr algn="ctr"/>
-            <a:r>
-              <a:rPr sz="1300" b="0">
-                <a:solidFill>
-                  <a:srgbClr val="F5F8FF"/>
-                </a:solidFill>
-                <a:latin typeface="Segoe UI"/>
-              </a:rPr>
-              <a:t>keyDistributor</a:t>
-            </a:r>
-          </a:p>
-          <a:p>
-            <a:pPr algn="ctr"/>
-            <a:r>
-              <a:rPr sz="1300" b="0">
-                <a:solidFill>
-                  <a:srgbClr val="F5F8FF"/>
-                </a:solidFill>
-                <a:latin typeface="Segoe UI"/>
-              </a:rPr>
-              <a:t>+ shared
-logging/stats/diag</a:t>
-            </a:r>
-          </a:p>
-        </p:txBody>
-      </p:sp>
-      <p:cxnSp>
-        <p:nvCxnSpPr>
-          <p:cNvPr id="10" name="Connector 9"/>
-          <p:cNvCxnSpPr/>
-          <p:nvPr/>
-        </p:nvCxnSpPr>
-        <p:spPr>
-          <a:xfrm>
-            <a:off x="3931920" y="2148840"/>
-            <a:ext cx="2743200" cy="0"/>
-          </a:xfrm>
-          <a:prstGeom prst="line">
-            <a:avLst/>
-          </a:prstGeom>
-          <a:ln w="19050">
-            <a:solidFill>
-              <a:srgbClr val="A9B8D6"/>
-            </a:solidFill>
-            <a:tailEnd type="triangle" w="med" len="med"/>
-          </a:ln>
-          <a:effectLst/>
-        </p:spPr>
-        <p:style>
-          <a:lnRef idx="2">
-            <a:schemeClr val="accent1"/>
-          </a:lnRef>
-          <a:fillRef idx="0">
-            <a:schemeClr val="accent1"/>
-          </a:fillRef>
-          <a:effectRef idx="1">
-            <a:schemeClr val="accent1"/>
-          </a:effectRef>
-          <a:fontRef idx="minor">
-            <a:schemeClr val="tx1"/>
-          </a:fontRef>
-        </p:style>
-      </p:cxnSp>
-      <p:sp>
-        <p:nvSpPr>
-          <p:cNvPr id="11" name="Rounded Rectangle 10"/>
-          <p:cNvSpPr/>
-          <p:nvPr/>
-        </p:nvSpPr>
-        <p:spPr>
-          <a:xfrm>
-            <a:off x="9144000" y="1645920"/>
-            <a:ext cx="2286000" cy="1005840"/>
-          </a:xfrm>
-          <a:prstGeom prst="roundRect">
-            <a:avLst/>
-          </a:prstGeom>
-          <a:solidFill>
-            <a:srgbClr val="1B2A4A"/>
-          </a:solidFill>
-          <a:ln w="15875">
-            <a:solidFill>
-              <a:srgbClr val="2E5C9E"/>
-            </a:solidFill>
-          </a:ln>
-          <a:effectLst/>
-        </p:spPr>
-        <p:style>
-          <a:lnRef idx="1">
-            <a:schemeClr val="accent1"/>
-          </a:lnRef>
-          <a:fillRef idx="3">
-            <a:schemeClr val="accent1"/>
-          </a:fillRef>
-          <a:effectRef idx="2">
-            <a:schemeClr val="accent1"/>
-          </a:effectRef>
-          <a:fontRef idx="minor">
-            <a:schemeClr val="lt1"/>
-          </a:fontRef>
-        </p:style>
-        <p:txBody>
-          <a:bodyPr rtlCol="0" anchor="ctr" wrap="square" lIns="73152" rIns="73152" tIns="36576" bIns="36576"/>
-          <a:lstStyle/>
-          <a:p>
-            <a:pPr algn="ctr"/>
-            <a:r>
-              <a:rPr sz="1300" b="0">
-                <a:solidFill>
-                  <a:srgbClr val="F5F8FF"/>
-                </a:solidFill>
-                <a:latin typeface="Segoe UI"/>
-              </a:rPr>
-              <a:t>client</a:t>
-            </a:r>
-          </a:p>
-          <a:p>
-            <a:pPr algn="ctr"/>
-            <a:r>
-              <a:rPr sz="1300" b="0">
-                <a:solidFill>
-                  <a:srgbClr val="F5F8FF"/>
-                </a:solidFill>
-                <a:latin typeface="Segoe UI"/>
-              </a:rPr>
-              <a:t>+ shared
-logging/stats/diag</a:t>
-            </a:r>
-          </a:p>
-        </p:txBody>
-      </p:sp>
-      <p:cxnSp>
-        <p:nvCxnSpPr>
-          <p:cNvPr id="12" name="Connector 11"/>
-          <p:cNvCxnSpPr/>
-          <p:nvPr/>
-        </p:nvCxnSpPr>
-        <p:spPr>
-          <a:xfrm>
-            <a:off x="3931920" y="2148840"/>
-            <a:ext cx="5212080" cy="0"/>
-          </a:xfrm>
-          <a:prstGeom prst="line">
-            <a:avLst/>
-          </a:prstGeom>
-          <a:ln w="19050">
-            <a:solidFill>
-              <a:srgbClr val="A9B8D6"/>
-            </a:solidFill>
-            <a:tailEnd type="triangle" w="med" len="med"/>
-          </a:ln>
-          <a:effectLst/>
-        </p:spPr>
-        <p:style>
-          <a:lnRef idx="2">
-            <a:schemeClr val="accent1"/>
-          </a:lnRef>
-          <a:fillRef idx="0">
-            <a:schemeClr val="accent1"/>
-          </a:fillRef>
-          <a:effectRef idx="1">
-            <a:schemeClr val="accent1"/>
-          </a:effectRef>
-          <a:fontRef idx="minor">
-            <a:schemeClr val="tx1"/>
-          </a:fontRef>
-        </p:style>
-      </p:cxnSp>
-      <p:sp>
-        <p:nvSpPr>
-          <p:cNvPr id="13" name="TextBox 12"/>
+            <a:pPr algn="l"/>
+            <a:r>
+              <a:rPr sz="1600" b="0">
+                <a:solidFill>
+                  <a:srgbClr val="F5F8FF"/>
+                </a:solidFill>
+                <a:latin typeface="Segoe UI"/>
+              </a:rPr>
+              <a:t>HIDDEN</a:t>
+            </a:r>
+          </a:p>
+          <a:p>
+            <a:pPr algn="l"/>
+            <a:r>
+              <a:rPr sz="1600" b="0">
+                <a:solidFill>
+                  <a:srgbClr val="F5F8FF"/>
+                </a:solidFill>
+                <a:latin typeface="Segoe UI"/>
+              </a:rPr>
+              <a:t/>
+            </a:r>
+          </a:p>
+          <a:p>
+            <a:pPr algn="l"/>
+            <a:r>
+              <a:rPr sz="1600" b="0">
+                <a:solidFill>
+                  <a:srgbClr val="F5F8FF"/>
+                </a:solidFill>
+                <a:latin typeface="Segoe UI"/>
+              </a:rPr>
+              <a:t>E2E media payload (inner GCM)</a:t>
+            </a:r>
+          </a:p>
+          <a:p>
+            <a:pPr algn="l"/>
+            <a:r>
+              <a:rPr sz="1600" b="0">
+                <a:solidFill>
+                  <a:srgbClr val="F5F8FF"/>
+                </a:solidFill>
+                <a:latin typeface="Segoe UI"/>
+              </a:rPr>
+              <a:t>The E2E key (KD + clients only)</a:t>
+            </a:r>
+          </a:p>
+          <a:p>
+            <a:pPr algn="l"/>
+            <a:r>
+              <a:rPr sz="1600" b="0">
+                <a:solidFill>
+                  <a:srgbClr val="F5F8FF"/>
+                </a:solidFill>
+                <a:latin typeface="Segoe UI"/>
+              </a:rPr>
+              <a:t>Decoded media / codec bitstream</a:t>
+            </a:r>
+          </a:p>
+          <a:p>
+            <a:pPr algn="l"/>
+            <a:r>
+              <a:rPr sz="1600" b="0">
+                <a:solidFill>
+                  <a:srgbClr val="F5F8FF"/>
+                </a:solidFill>
+                <a:latin typeface="Segoe UI"/>
+              </a:rPr>
+              <a:t>Inner header extensions</a:t>
+            </a:r>
+          </a:p>
+        </p:txBody>
+      </p:sp>
+      <p:sp>
+        <p:nvSpPr>
+          <p:cNvPr id="8" name="TextBox 7"/>
           <p:cNvSpPr txBox="1"/>
           <p:nvPr/>
         </p:nvSpPr>
         <p:spPr>
           <a:xfrm>
-            <a:off x="640080" y="3017520"/>
-            <a:ext cx="10789920" cy="4572000"/>
-          </a:xfrm>
-          <a:prstGeom prst="rect">
-            <a:avLst/>
-          </a:prstGeom>
-          <a:noFill/>
-        </p:spPr>
-        <p:txBody>
-          <a:bodyPr wrap="square">
-            <a:spAutoFit/>
-          </a:bodyPr>
-          <a:lstStyle/>
-          <a:p>
-            <a:pPr>
-              <a:spcAft>
-                <a:spcPts val="1152"/>
-              </a:spcAft>
-            </a:pPr>
-            <a:r>
-              <a:rPr sz="1800">
-                <a:solidFill>
-                  <a:srgbClr val="F5F8FF"/>
-                </a:solidFill>
-                <a:latin typeface="Segoe UI"/>
-              </a:rPr>
-              <a:t>• Resolution: --config (repeatable, deep-merge) → E2EE_CONFIG env → ./config.json.</a:t>
-            </a:r>
-          </a:p>
-          <a:p>
-            <a:pPr>
-              <a:spcAft>
-                <a:spcPts val="1152"/>
-              </a:spcAft>
-            </a:pPr>
-            <a:r>
-              <a:rPr sz="1800">
-                <a:solidFill>
-                  <a:srgbClr val="F5F8FF"/>
-                </a:solidFill>
-                <a:latin typeface="Segoe UI"/>
-              </a:rPr>
-              <a:t>• Same loader handles one combined file or per-host flat files; JSONC + trailing commas.</a:t>
-            </a:r>
-          </a:p>
-          <a:p>
-            <a:pPr>
-              <a:spcAft>
-                <a:spcPts val="1152"/>
-              </a:spcAft>
-            </a:pPr>
-            <a:r>
-              <a:rPr sz="1800">
-                <a:solidFill>
-                  <a:srgbClr val="F5F8FF"/>
-                </a:solidFill>
-                <a:latin typeface="Segoe UI"/>
-              </a:rPr>
-              <a:t>• Node apps share config-loader.js; str0m uses a matching loader in examples/util.</a:t>
-            </a:r>
-          </a:p>
-          <a:p>
-            <a:pPr>
-              <a:spcAft>
-                <a:spcPts val="1152"/>
-              </a:spcAft>
-            </a:pPr>
-            <a:r>
-              <a:rPr sz="1800">
-                <a:solidFill>
-                  <a:srgbClr val="F5F8FF"/>
-                </a:solidFill>
-                <a:latin typeface="Segoe UI"/>
-              </a:rPr>
-              <a:t>• Client pushes media params to native via env vars (width/height/fps/bitrate/codec).</a:t>
-            </a:r>
-          </a:p>
-          <a:p>
-            <a:pPr>
-              <a:spcAft>
-                <a:spcPts val="1152"/>
-              </a:spcAft>
-            </a:pPr>
-            <a:r>
-              <a:rPr sz="1800">
-                <a:solidFill>
-                  <a:srgbClr val="F5F8FF"/>
-                </a:solidFill>
-                <a:latin typeface="Segoe UI"/>
-              </a:rPr>
-              <a:t>• Toggles: log-to-file, periodic stats, wire log, per-frame E2E diagnostics.</a:t>
-            </a:r>
-          </a:p>
-          <a:p>
-            <a:pPr>
-              <a:spcAft>
-                <a:spcPts val="1152"/>
-              </a:spcAft>
-            </a:pPr>
-            <a:r>
-              <a:rPr sz="1800">
-                <a:solidFill>
-                  <a:srgbClr val="F5F8FF"/>
-                </a:solidFill>
-                <a:latin typeface="Segoe UI"/>
-              </a:rPr>
-              <a:t>• run-all.ps1 launches SFU + KD + two clients against the shared config.</a:t>
-            </a:r>
-          </a:p>
-        </p:txBody>
-      </p:sp>
-      <p:sp>
-        <p:nvSpPr>
-          <p:cNvPr id="14" name="TextBox 13"/>
-          <p:cNvSpPr txBox="1"/>
-          <p:nvPr/>
-        </p:nvSpPr>
-        <p:spPr>
-          <a:xfrm>
-            <a:off x="548640" y="6446520"/>
-            <a:ext cx="7315200" cy="320040"/>
+            <a:off x="640080" y="5303520"/>
+            <a:ext cx="10881360" cy="640080"/>
           </a:xfrm>
           <a:prstGeom prst="rect">
             <a:avLst/>
@@ -6274,6 +6237,41 @@
           </a:bodyPr>
           <a:lstStyle/>
           <a:p>
+            <a:pPr algn="ctr"/>
+            <a:r>
+              <a:rPr sz="1500" b="0">
+                <a:solidFill>
+                  <a:srgbClr val="A9B8D6"/>
+                </a:solidFill>
+                <a:latin typeface="Segoe UI"/>
+              </a:rPr>
+              <a:t>Server compromise leaks routing metadata only — never the media content.</a:t>
+            </a:r>
+          </a:p>
+        </p:txBody>
+      </p:sp>
+      <p:sp>
+        <p:nvSpPr>
+          <p:cNvPr id="9" name="TextBox 8"/>
+          <p:cNvSpPr txBox="1"/>
+          <p:nvPr/>
+        </p:nvSpPr>
+        <p:spPr>
+          <a:xfrm>
+            <a:off x="548640" y="6446520"/>
+            <a:ext cx="7315200" cy="320040"/>
+          </a:xfrm>
+          <a:prstGeom prst="rect">
+            <a:avLst/>
+          </a:prstGeom>
+          <a:noFill/>
+        </p:spPr>
+        <p:txBody>
+          <a:bodyPr wrap="square" anchor="t">
+            <a:spAutoFit/>
+          </a:bodyPr>
+          <a:lstStyle/>
+          <a:p>
             <a:pPr algn="l"/>
             <a:r>
               <a:rPr sz="1000" b="0">
@@ -6289,7 +6287,7 @@
       </p:sp>
       <p:sp>
         <p:nvSpPr>
-          <p:cNvPr id="15" name="TextBox 14"/>
+          <p:cNvPr id="10" name="TextBox 9"/>
           <p:cNvSpPr txBox="1"/>
           <p:nvPr/>
         </p:nvSpPr>
@@ -6458,7 +6456,7 @@
                 </a:solidFill>
                 <a:latin typeface="Segoe UI"/>
               </a:rPr>
-              <a:t>ROADMAP</a:t>
+              <a:t>OPERATIONS</a:t>
             </a:r>
           </a:p>
         </p:txBody>
@@ -6493,7 +6491,7 @@
                 </a:solidFill>
                 <a:latin typeface="Segoe UI"/>
               </a:rPr>
-              <a:t>Done &amp; what's next</a:t>
+              <a:t>Unified configuration system</a:t>
             </a:r>
           </a:p>
         </p:txBody>
@@ -6506,8 +6504,180 @@
         </p:nvSpPr>
         <p:spPr>
           <a:xfrm>
-            <a:off x="640080" y="1737360"/>
-            <a:ext cx="5303520" cy="3108960"/>
+            <a:off x="640080" y="1645920"/>
+            <a:ext cx="3291840" cy="1005840"/>
+          </a:xfrm>
+          <a:prstGeom prst="roundRect">
+            <a:avLst/>
+          </a:prstGeom>
+          <a:solidFill>
+            <a:srgbClr val="1B2A4A"/>
+          </a:solidFill>
+          <a:ln w="15875">
+            <a:solidFill>
+              <a:srgbClr val="4C9AFF"/>
+            </a:solidFill>
+          </a:ln>
+          <a:effectLst/>
+        </p:spPr>
+        <p:style>
+          <a:lnRef idx="1">
+            <a:schemeClr val="accent1"/>
+          </a:lnRef>
+          <a:fillRef idx="3">
+            <a:schemeClr val="accent1"/>
+          </a:fillRef>
+          <a:effectRef idx="2">
+            <a:schemeClr val="accent1"/>
+          </a:effectRef>
+          <a:fontRef idx="minor">
+            <a:schemeClr val="lt1"/>
+          </a:fontRef>
+        </p:style>
+        <p:txBody>
+          <a:bodyPr rtlCol="0" anchor="ctr" wrap="square" lIns="73152" rIns="73152" tIns="36576" bIns="36576"/>
+          <a:lstStyle/>
+          <a:p>
+            <a:pPr algn="ctr"/>
+            <a:r>
+              <a:rPr sz="1400" b="1">
+                <a:solidFill>
+                  <a:srgbClr val="F5F8FF"/>
+                </a:solidFill>
+                <a:latin typeface="Segoe UI"/>
+              </a:rPr>
+              <a:t>config.json (JSONC)</a:t>
+            </a:r>
+          </a:p>
+          <a:p>
+            <a:pPr algn="ctr"/>
+            <a:r>
+              <a:rPr sz="1400" b="1">
+                <a:solidFill>
+                  <a:srgbClr val="F5F8FF"/>
+                </a:solidFill>
+                <a:latin typeface="Segoe UI"/>
+              </a:rPr>
+              <a:t>sectioned OR flat</a:t>
+            </a:r>
+          </a:p>
+        </p:txBody>
+      </p:sp>
+      <p:sp>
+        <p:nvSpPr>
+          <p:cNvPr id="7" name="Rounded Rectangle 6"/>
+          <p:cNvSpPr/>
+          <p:nvPr/>
+        </p:nvSpPr>
+        <p:spPr>
+          <a:xfrm>
+            <a:off x="4206240" y="1645920"/>
+            <a:ext cx="2286000" cy="1005840"/>
+          </a:xfrm>
+          <a:prstGeom prst="roundRect">
+            <a:avLst/>
+          </a:prstGeom>
+          <a:solidFill>
+            <a:srgbClr val="1B2A4A"/>
+          </a:solidFill>
+          <a:ln w="15875">
+            <a:solidFill>
+              <a:srgbClr val="4C9AFF"/>
+            </a:solidFill>
+          </a:ln>
+          <a:effectLst/>
+        </p:spPr>
+        <p:style>
+          <a:lnRef idx="1">
+            <a:schemeClr val="accent1"/>
+          </a:lnRef>
+          <a:fillRef idx="3">
+            <a:schemeClr val="accent1"/>
+          </a:fillRef>
+          <a:effectRef idx="2">
+            <a:schemeClr val="accent1"/>
+          </a:effectRef>
+          <a:fontRef idx="minor">
+            <a:schemeClr val="lt1"/>
+          </a:fontRef>
+        </p:style>
+        <p:txBody>
+          <a:bodyPr rtlCol="0" anchor="ctr" wrap="square" lIns="73152" rIns="73152" tIns="36576" bIns="36576"/>
+          <a:lstStyle/>
+          <a:p>
+            <a:pPr algn="ctr"/>
+            <a:r>
+              <a:rPr sz="1300" b="0">
+                <a:solidFill>
+                  <a:srgbClr val="F5F8FF"/>
+                </a:solidFill>
+                <a:latin typeface="Segoe UI"/>
+              </a:rPr>
+              <a:t>sfu</a:t>
+            </a:r>
+          </a:p>
+          <a:p>
+            <a:pPr algn="ctr"/>
+            <a:r>
+              <a:rPr sz="1300" b="0">
+                <a:solidFill>
+                  <a:srgbClr val="F5F8FF"/>
+                </a:solidFill>
+                <a:latin typeface="Segoe UI"/>
+              </a:rPr>
+              <a:t>+ shared
+logging/stats/diag</a:t>
+            </a:r>
+          </a:p>
+        </p:txBody>
+      </p:sp>
+      <p:cxnSp>
+        <p:nvCxnSpPr>
+          <p:cNvPr id="8" name="Connector 7"/>
+          <p:cNvCxnSpPr/>
+          <p:nvPr/>
+        </p:nvCxnSpPr>
+        <p:spPr>
+          <a:xfrm>
+            <a:off x="3931920" y="2148840"/>
+            <a:ext cx="274320" cy="0"/>
+          </a:xfrm>
+          <a:prstGeom prst="line">
+            <a:avLst/>
+          </a:prstGeom>
+          <a:ln w="19050">
+            <a:solidFill>
+              <a:srgbClr val="A9B8D6"/>
+            </a:solidFill>
+            <a:tailEnd type="triangle" w="med" len="med"/>
+          </a:ln>
+          <a:effectLst/>
+        </p:spPr>
+        <p:style>
+          <a:lnRef idx="2">
+            <a:schemeClr val="accent1"/>
+          </a:lnRef>
+          <a:fillRef idx="0">
+            <a:schemeClr val="accent1"/>
+          </a:fillRef>
+          <a:effectRef idx="1">
+            <a:schemeClr val="accent1"/>
+          </a:effectRef>
+          <a:fontRef idx="minor">
+            <a:schemeClr val="tx1"/>
+          </a:fontRef>
+        </p:style>
+      </p:cxnSp>
+      <p:sp>
+        <p:nvSpPr>
+          <p:cNvPr id="9" name="Rounded Rectangle 8"/>
+          <p:cNvSpPr/>
+          <p:nvPr/>
+        </p:nvSpPr>
+        <p:spPr>
+          <a:xfrm>
+            <a:off x="6675120" y="1645920"/>
+            <a:ext cx="2286000" cy="1005840"/>
           </a:xfrm>
           <a:prstGeom prst="roundRect">
             <a:avLst/>
@@ -6540,8 +6710,583 @@
           <a:bodyPr rtlCol="0" anchor="ctr" wrap="square" lIns="73152" rIns="73152" tIns="36576" bIns="36576"/>
           <a:lstStyle/>
           <a:p>
+            <a:pPr algn="ctr"/>
+            <a:r>
+              <a:rPr sz="1300" b="0">
+                <a:solidFill>
+                  <a:srgbClr val="F5F8FF"/>
+                </a:solidFill>
+                <a:latin typeface="Segoe UI"/>
+              </a:rPr>
+              <a:t>keyDistributor</a:t>
+            </a:r>
+          </a:p>
+          <a:p>
+            <a:pPr algn="ctr"/>
+            <a:r>
+              <a:rPr sz="1300" b="0">
+                <a:solidFill>
+                  <a:srgbClr val="F5F8FF"/>
+                </a:solidFill>
+                <a:latin typeface="Segoe UI"/>
+              </a:rPr>
+              <a:t>+ shared
+logging/stats/diag</a:t>
+            </a:r>
+          </a:p>
+        </p:txBody>
+      </p:sp>
+      <p:cxnSp>
+        <p:nvCxnSpPr>
+          <p:cNvPr id="10" name="Connector 9"/>
+          <p:cNvCxnSpPr/>
+          <p:nvPr/>
+        </p:nvCxnSpPr>
+        <p:spPr>
+          <a:xfrm>
+            <a:off x="3931920" y="2148840"/>
+            <a:ext cx="2743200" cy="0"/>
+          </a:xfrm>
+          <a:prstGeom prst="line">
+            <a:avLst/>
+          </a:prstGeom>
+          <a:ln w="19050">
+            <a:solidFill>
+              <a:srgbClr val="A9B8D6"/>
+            </a:solidFill>
+            <a:tailEnd type="triangle" w="med" len="med"/>
+          </a:ln>
+          <a:effectLst/>
+        </p:spPr>
+        <p:style>
+          <a:lnRef idx="2">
+            <a:schemeClr val="accent1"/>
+          </a:lnRef>
+          <a:fillRef idx="0">
+            <a:schemeClr val="accent1"/>
+          </a:fillRef>
+          <a:effectRef idx="1">
+            <a:schemeClr val="accent1"/>
+          </a:effectRef>
+          <a:fontRef idx="minor">
+            <a:schemeClr val="tx1"/>
+          </a:fontRef>
+        </p:style>
+      </p:cxnSp>
+      <p:sp>
+        <p:nvSpPr>
+          <p:cNvPr id="11" name="Rounded Rectangle 10"/>
+          <p:cNvSpPr/>
+          <p:nvPr/>
+        </p:nvSpPr>
+        <p:spPr>
+          <a:xfrm>
+            <a:off x="9144000" y="1645920"/>
+            <a:ext cx="2286000" cy="1005840"/>
+          </a:xfrm>
+          <a:prstGeom prst="roundRect">
+            <a:avLst/>
+          </a:prstGeom>
+          <a:solidFill>
+            <a:srgbClr val="1B2A4A"/>
+          </a:solidFill>
+          <a:ln w="15875">
+            <a:solidFill>
+              <a:srgbClr val="2E5C9E"/>
+            </a:solidFill>
+          </a:ln>
+          <a:effectLst/>
+        </p:spPr>
+        <p:style>
+          <a:lnRef idx="1">
+            <a:schemeClr val="accent1"/>
+          </a:lnRef>
+          <a:fillRef idx="3">
+            <a:schemeClr val="accent1"/>
+          </a:fillRef>
+          <a:effectRef idx="2">
+            <a:schemeClr val="accent1"/>
+          </a:effectRef>
+          <a:fontRef idx="minor">
+            <a:schemeClr val="lt1"/>
+          </a:fontRef>
+        </p:style>
+        <p:txBody>
+          <a:bodyPr rtlCol="0" anchor="ctr" wrap="square" lIns="73152" rIns="73152" tIns="36576" bIns="36576"/>
+          <a:lstStyle/>
+          <a:p>
+            <a:pPr algn="ctr"/>
+            <a:r>
+              <a:rPr sz="1300" b="0">
+                <a:solidFill>
+                  <a:srgbClr val="F5F8FF"/>
+                </a:solidFill>
+                <a:latin typeface="Segoe UI"/>
+              </a:rPr>
+              <a:t>client</a:t>
+            </a:r>
+          </a:p>
+          <a:p>
+            <a:pPr algn="ctr"/>
+            <a:r>
+              <a:rPr sz="1300" b="0">
+                <a:solidFill>
+                  <a:srgbClr val="F5F8FF"/>
+                </a:solidFill>
+                <a:latin typeface="Segoe UI"/>
+              </a:rPr>
+              <a:t>+ shared
+logging/stats/diag</a:t>
+            </a:r>
+          </a:p>
+        </p:txBody>
+      </p:sp>
+      <p:cxnSp>
+        <p:nvCxnSpPr>
+          <p:cNvPr id="12" name="Connector 11"/>
+          <p:cNvCxnSpPr/>
+          <p:nvPr/>
+        </p:nvCxnSpPr>
+        <p:spPr>
+          <a:xfrm>
+            <a:off x="3931920" y="2148840"/>
+            <a:ext cx="5212080" cy="0"/>
+          </a:xfrm>
+          <a:prstGeom prst="line">
+            <a:avLst/>
+          </a:prstGeom>
+          <a:ln w="19050">
+            <a:solidFill>
+              <a:srgbClr val="A9B8D6"/>
+            </a:solidFill>
+            <a:tailEnd type="triangle" w="med" len="med"/>
+          </a:ln>
+          <a:effectLst/>
+        </p:spPr>
+        <p:style>
+          <a:lnRef idx="2">
+            <a:schemeClr val="accent1"/>
+          </a:lnRef>
+          <a:fillRef idx="0">
+            <a:schemeClr val="accent1"/>
+          </a:fillRef>
+          <a:effectRef idx="1">
+            <a:schemeClr val="accent1"/>
+          </a:effectRef>
+          <a:fontRef idx="minor">
+            <a:schemeClr val="tx1"/>
+          </a:fontRef>
+        </p:style>
+      </p:cxnSp>
+      <p:sp>
+        <p:nvSpPr>
+          <p:cNvPr id="13" name="TextBox 12"/>
+          <p:cNvSpPr txBox="1"/>
+          <p:nvPr/>
+        </p:nvSpPr>
+        <p:spPr>
+          <a:xfrm>
+            <a:off x="640080" y="3017520"/>
+            <a:ext cx="10789920" cy="4572000"/>
+          </a:xfrm>
+          <a:prstGeom prst="rect">
+            <a:avLst/>
+          </a:prstGeom>
+          <a:noFill/>
+        </p:spPr>
+        <p:txBody>
+          <a:bodyPr wrap="square">
+            <a:spAutoFit/>
+          </a:bodyPr>
+          <a:lstStyle/>
+          <a:p>
+            <a:pPr>
+              <a:spcAft>
+                <a:spcPts val="1152"/>
+              </a:spcAft>
+            </a:pPr>
+            <a:r>
+              <a:rPr sz="1800">
+                <a:solidFill>
+                  <a:srgbClr val="F5F8FF"/>
+                </a:solidFill>
+                <a:latin typeface="Segoe UI"/>
+              </a:rPr>
+              <a:t>• Resolution: --config (repeatable, deep-merge) → E2EE_CONFIG env → ./config.json.</a:t>
+            </a:r>
+          </a:p>
+          <a:p>
+            <a:pPr>
+              <a:spcAft>
+                <a:spcPts val="1152"/>
+              </a:spcAft>
+            </a:pPr>
+            <a:r>
+              <a:rPr sz="1800">
+                <a:solidFill>
+                  <a:srgbClr val="F5F8FF"/>
+                </a:solidFill>
+                <a:latin typeface="Segoe UI"/>
+              </a:rPr>
+              <a:t>• Same loader handles one combined file or per-host flat files; JSONC + trailing commas.</a:t>
+            </a:r>
+          </a:p>
+          <a:p>
+            <a:pPr>
+              <a:spcAft>
+                <a:spcPts val="1152"/>
+              </a:spcAft>
+            </a:pPr>
+            <a:r>
+              <a:rPr sz="1800">
+                <a:solidFill>
+                  <a:srgbClr val="F5F8FF"/>
+                </a:solidFill>
+                <a:latin typeface="Segoe UI"/>
+              </a:rPr>
+              <a:t>• Node apps share config-loader.js; str0m uses a matching loader in examples/util.</a:t>
+            </a:r>
+          </a:p>
+          <a:p>
+            <a:pPr>
+              <a:spcAft>
+                <a:spcPts val="1152"/>
+              </a:spcAft>
+            </a:pPr>
+            <a:r>
+              <a:rPr sz="1800">
+                <a:solidFill>
+                  <a:srgbClr val="F5F8FF"/>
+                </a:solidFill>
+                <a:latin typeface="Segoe UI"/>
+              </a:rPr>
+              <a:t>• Client pushes media params to native via env vars (width/height/fps/bitrate/codec).</a:t>
+            </a:r>
+          </a:p>
+          <a:p>
+            <a:pPr>
+              <a:spcAft>
+                <a:spcPts val="1152"/>
+              </a:spcAft>
+            </a:pPr>
+            <a:r>
+              <a:rPr sz="1800">
+                <a:solidFill>
+                  <a:srgbClr val="F5F8FF"/>
+                </a:solidFill>
+                <a:latin typeface="Segoe UI"/>
+              </a:rPr>
+              <a:t>• Toggles: log-to-file, periodic stats, wire log, per-frame E2E diagnostics.</a:t>
+            </a:r>
+          </a:p>
+          <a:p>
+            <a:pPr>
+              <a:spcAft>
+                <a:spcPts val="1152"/>
+              </a:spcAft>
+            </a:pPr>
+            <a:r>
+              <a:rPr sz="1800">
+                <a:solidFill>
+                  <a:srgbClr val="F5F8FF"/>
+                </a:solidFill>
+                <a:latin typeface="Segoe UI"/>
+              </a:rPr>
+              <a:t>• run-all.ps1 launches SFU + KD + N clients (default alice/bob/carol) against the shared config.</a:t>
+            </a:r>
+          </a:p>
+        </p:txBody>
+      </p:sp>
+      <p:sp>
+        <p:nvSpPr>
+          <p:cNvPr id="14" name="TextBox 13"/>
+          <p:cNvSpPr txBox="1"/>
+          <p:nvPr/>
+        </p:nvSpPr>
+        <p:spPr>
+          <a:xfrm>
+            <a:off x="548640" y="6446520"/>
+            <a:ext cx="7315200" cy="320040"/>
+          </a:xfrm>
+          <a:prstGeom prst="rect">
+            <a:avLst/>
+          </a:prstGeom>
+          <a:noFill/>
+        </p:spPr>
+        <p:txBody>
+          <a:bodyPr wrap="square" anchor="t">
+            <a:spAutoFit/>
+          </a:bodyPr>
+          <a:lstStyle/>
+          <a:p>
             <a:pPr algn="l"/>
             <a:r>
+              <a:rPr sz="1000" b="0">
+                <a:solidFill>
+                  <a:srgbClr val="A9B8D6"/>
+                </a:solidFill>
+                <a:latin typeface="Segoe UI"/>
+              </a:rPr>
+              <a:t>E2EE WebRTC — Zero-Trust SFU (str0m + PERC)</a:t>
+            </a:r>
+          </a:p>
+        </p:txBody>
+      </p:sp>
+      <p:sp>
+        <p:nvSpPr>
+          <p:cNvPr id="15" name="TextBox 14"/>
+          <p:cNvSpPr txBox="1"/>
+          <p:nvPr/>
+        </p:nvSpPr>
+        <p:spPr>
+          <a:xfrm>
+            <a:off x="11155680" y="6446520"/>
+            <a:ext cx="822960" cy="320040"/>
+          </a:xfrm>
+          <a:prstGeom prst="rect">
+            <a:avLst/>
+          </a:prstGeom>
+          <a:noFill/>
+        </p:spPr>
+        <p:txBody>
+          <a:bodyPr wrap="square" anchor="t">
+            <a:spAutoFit/>
+          </a:bodyPr>
+          <a:lstStyle/>
+          <a:p>
+            <a:pPr algn="r"/>
+            <a:r>
+              <a:rPr sz="1000" b="0">
+                <a:solidFill>
+                  <a:srgbClr val="A9B8D6"/>
+                </a:solidFill>
+                <a:latin typeface="Segoe UI"/>
+              </a:rPr>
+              <a:t>14</a:t>
+            </a:r>
+          </a:p>
+        </p:txBody>
+      </p:sp>
+    </p:spTree>
+  </p:cSld>
+  <p:clrMapOvr>
+    <a:masterClrMapping/>
+  </p:clrMapOvr>
+</p:sld>
+</file>
+
+<file path=ppt/slides/slide16.xml><?xml version="1.0" encoding="utf-8"?>
+<p:sld xmlns:a="http://schemas.openxmlformats.org/drawingml/2006/main" xmlns:p="http://schemas.openxmlformats.org/presentationml/2006/main" xmlns:r="http://schemas.openxmlformats.org/officeDocument/2006/relationships">
+  <p:cSld>
+    <p:spTree>
+      <p:nvGrpSpPr>
+        <p:cNvPr id="1" name=""/>
+        <p:cNvGrpSpPr/>
+        <p:nvPr/>
+      </p:nvGrpSpPr>
+      <p:grpSpPr/>
+      <p:sp>
+        <p:nvSpPr>
+          <p:cNvPr id="2" name="Rectangle 1"/>
+          <p:cNvSpPr/>
+          <p:nvPr/>
+        </p:nvSpPr>
+        <p:spPr>
+          <a:xfrm>
+            <a:off x="0" y="0"/>
+            <a:ext cx="12191695" cy="6858000"/>
+          </a:xfrm>
+          <a:prstGeom prst="rect">
+            <a:avLst/>
+          </a:prstGeom>
+          <a:solidFill>
+            <a:srgbClr val="0F172A"/>
+          </a:solidFill>
+          <a:ln>
+            <a:noFill/>
+          </a:ln>
+          <a:effectLst/>
+        </p:spPr>
+        <p:style>
+          <a:lnRef idx="1">
+            <a:schemeClr val="accent1"/>
+          </a:lnRef>
+          <a:fillRef idx="3">
+            <a:schemeClr val="accent1"/>
+          </a:fillRef>
+          <a:effectRef idx="2">
+            <a:schemeClr val="accent1"/>
+          </a:effectRef>
+          <a:fontRef idx="minor">
+            <a:schemeClr val="lt1"/>
+          </a:fontRef>
+        </p:style>
+        <p:txBody>
+          <a:bodyPr rtlCol="0" anchor="ctr"/>
+          <a:lstStyle/>
+          <a:p>
+            <a:pPr algn="ctr"/>
+          </a:p>
+        </p:txBody>
+      </p:sp>
+      <p:sp>
+        <p:nvSpPr>
+          <p:cNvPr id="3" name="Rectangle 2"/>
+          <p:cNvSpPr/>
+          <p:nvPr/>
+        </p:nvSpPr>
+        <p:spPr>
+          <a:xfrm>
+            <a:off x="0" y="0"/>
+            <a:ext cx="12191695" cy="146304"/>
+          </a:xfrm>
+          <a:prstGeom prst="rect">
+            <a:avLst/>
+          </a:prstGeom>
+          <a:solidFill>
+            <a:srgbClr val="4C9AFF"/>
+          </a:solidFill>
+          <a:ln>
+            <a:noFill/>
+          </a:ln>
+          <a:effectLst/>
+        </p:spPr>
+        <p:style>
+          <a:lnRef idx="1">
+            <a:schemeClr val="accent1"/>
+          </a:lnRef>
+          <a:fillRef idx="3">
+            <a:schemeClr val="accent1"/>
+          </a:fillRef>
+          <a:effectRef idx="2">
+            <a:schemeClr val="accent1"/>
+          </a:effectRef>
+          <a:fontRef idx="minor">
+            <a:schemeClr val="lt1"/>
+          </a:fontRef>
+        </p:style>
+        <p:txBody>
+          <a:bodyPr rtlCol="0" anchor="ctr"/>
+          <a:lstStyle/>
+          <a:p>
+            <a:pPr algn="ctr"/>
+          </a:p>
+        </p:txBody>
+      </p:sp>
+      <p:sp>
+        <p:nvSpPr>
+          <p:cNvPr id="4" name="TextBox 3"/>
+          <p:cNvSpPr txBox="1"/>
+          <p:nvPr/>
+        </p:nvSpPr>
+        <p:spPr>
+          <a:xfrm>
+            <a:off x="548640" y="274320"/>
+            <a:ext cx="10058400" cy="365760"/>
+          </a:xfrm>
+          <a:prstGeom prst="rect">
+            <a:avLst/>
+          </a:prstGeom>
+          <a:noFill/>
+        </p:spPr>
+        <p:txBody>
+          <a:bodyPr wrap="square" anchor="t">
+            <a:spAutoFit/>
+          </a:bodyPr>
+          <a:lstStyle/>
+          <a:p>
+            <a:pPr algn="l"/>
+            <a:r>
+              <a:rPr sz="1300" b="1">
+                <a:solidFill>
+                  <a:srgbClr val="35D09B"/>
+                </a:solidFill>
+                <a:latin typeface="Segoe UI"/>
+              </a:rPr>
+              <a:t>ROADMAP</a:t>
+            </a:r>
+          </a:p>
+        </p:txBody>
+      </p:sp>
+      <p:sp>
+        <p:nvSpPr>
+          <p:cNvPr id="5" name="TextBox 4"/>
+          <p:cNvSpPr txBox="1"/>
+          <p:nvPr/>
+        </p:nvSpPr>
+        <p:spPr>
+          <a:xfrm>
+            <a:off x="548640" y="566928"/>
+            <a:ext cx="11064240" cy="822960"/>
+          </a:xfrm>
+          <a:prstGeom prst="rect">
+            <a:avLst/>
+          </a:prstGeom>
+          <a:noFill/>
+        </p:spPr>
+        <p:txBody>
+          <a:bodyPr wrap="square" anchor="t">
+            <a:spAutoFit/>
+          </a:bodyPr>
+          <a:lstStyle/>
+          <a:p>
+            <a:pPr algn="l"/>
+            <a:r>
+              <a:rPr sz="3000" b="1">
+                <a:solidFill>
+                  <a:srgbClr val="F5F8FF"/>
+                </a:solidFill>
+                <a:latin typeface="Segoe UI"/>
+              </a:rPr>
+              <a:t>Done &amp; what's next</a:t>
+            </a:r>
+          </a:p>
+        </p:txBody>
+      </p:sp>
+      <p:sp>
+        <p:nvSpPr>
+          <p:cNvPr id="6" name="Rounded Rectangle 5"/>
+          <p:cNvSpPr/>
+          <p:nvPr/>
+        </p:nvSpPr>
+        <p:spPr>
+          <a:xfrm>
+            <a:off x="640080" y="1737360"/>
+            <a:ext cx="5303520" cy="3108960"/>
+          </a:xfrm>
+          <a:prstGeom prst="roundRect">
+            <a:avLst/>
+          </a:prstGeom>
+          <a:solidFill>
+            <a:srgbClr val="1B2A4A"/>
+          </a:solidFill>
+          <a:ln w="15875">
+            <a:solidFill>
+              <a:srgbClr val="35D09B"/>
+            </a:solidFill>
+          </a:ln>
+          <a:effectLst/>
+        </p:spPr>
+        <p:style>
+          <a:lnRef idx="1">
+            <a:schemeClr val="accent1"/>
+          </a:lnRef>
+          <a:fillRef idx="3">
+            <a:schemeClr val="accent1"/>
+          </a:fillRef>
+          <a:effectRef idx="2">
+            <a:schemeClr val="accent1"/>
+          </a:effectRef>
+          <a:fontRef idx="minor">
+            <a:schemeClr val="lt1"/>
+          </a:fontRef>
+        </p:style>
+        <p:txBody>
+          <a:bodyPr rtlCol="0" anchor="ctr" wrap="square" lIns="73152" rIns="73152" tIns="36576" bIns="36576"/>
+          <a:lstStyle/>
+          <a:p>
+            <a:pPr algn="l"/>
+            <a:r>
               <a:rPr sz="1500" b="0">
                 <a:solidFill>
                   <a:srgbClr val="F5F8FF"/>
@@ -6608,7 +7353,7 @@
                 </a:solidFill>
                 <a:latin typeface="Segoe UI"/>
               </a:rPr>
-              <a:t>VP8 keyframe marker</a:t>
+              <a:t>VP8 keyframe marker · PLI/FIR relay</a:t>
             </a:r>
           </a:p>
           <a:p>
@@ -6620,7 +7365,7 @@
                 </a:solidFill>
                 <a:latin typeface="Segoe UI"/>
               </a:rPr>
-              <a:t>Keyframe (PLI/FIR) relay</a:t>
+              <a:t>Multi-party N:N (dynamic reneg)</a:t>
             </a:r>
           </a:p>
           <a:p>
@@ -6723,7 +7468,7 @@
                 </a:solidFill>
                 <a:latin typeface="Segoe UI"/>
               </a:rPr>
-              <a:t>Multi-party (N:N) routing</a:t>
+              <a:t>EKT (RFC 8870) key transport</a:t>
             </a:r>
           </a:p>
           <a:p>
@@ -6735,7 +7480,7 @@
                 </a:solidFill>
                 <a:latin typeface="Segoe UI"/>
               </a:rPr>
-              <a:t>EKT (RFC 8870) key transport</a:t>
+              <a:t>Certificate pinning to identity</a:t>
             </a:r>
           </a:p>
           <a:p>
@@ -6747,7 +7492,7 @@
                 </a:solidFill>
                 <a:latin typeface="Segoe UI"/>
               </a:rPr>
-              <a:t>Certificate pinning to identity</a:t>
+              <a:t>Encrypted headers (Cryptex)</a:t>
             </a:r>
           </a:p>
           <a:p>
@@ -6759,7 +7504,7 @@
                 </a:solidFill>
                 <a:latin typeface="Segoe UI"/>
               </a:rPr>
-              <a:t>Encrypted headers (Cryptex)</a:t>
+              <a:t>MLS group key agreement</a:t>
             </a:r>
           </a:p>
           <a:p>
@@ -6771,7 +7516,7 @@
                 </a:solidFill>
                 <a:latin typeface="Segoe UI"/>
               </a:rPr>
-              <a:t>MLS group key agreement</a:t>
+              <a:t>Simulcast / layer selection</a:t>
             </a:r>
           </a:p>
         </p:txBody>
@@ -6841,7 +7586,7 @@
                 </a:solidFill>
                 <a:latin typeface="Segoe UI"/>
               </a:rPr>
-              <a:t>14</a:t>
+              <a:t>15</a:t>
             </a:r>
           </a:p>
         </p:txBody>
@@ -8234,8 +8979,8 @@
         </p:nvSpPr>
         <p:spPr>
           <a:xfrm>
-            <a:off x="640080" y="1737360"/>
-            <a:ext cx="10881360" cy="1097280"/>
+            <a:off x="640080" y="1554480"/>
+            <a:ext cx="10881360" cy="914400"/>
           </a:xfrm>
           <a:prstGeom prst="roundRect">
             <a:avLst/>
@@ -8289,8 +9034,8 @@
         </p:nvSpPr>
         <p:spPr>
           <a:xfrm>
-            <a:off x="640080" y="3017520"/>
-            <a:ext cx="10881360" cy="1097280"/>
+            <a:off x="640080" y="2606040"/>
+            <a:ext cx="10881360" cy="914400"/>
           </a:xfrm>
           <a:prstGeom prst="roundRect">
             <a:avLst/>
@@ -8344,8 +9089,63 @@
         </p:nvSpPr>
         <p:spPr>
           <a:xfrm>
-            <a:off x="640080" y="4480560"/>
-            <a:ext cx="10881360" cy="1188720"/>
+            <a:off x="640080" y="3657600"/>
+            <a:ext cx="10881360" cy="914400"/>
+          </a:xfrm>
+          <a:prstGeom prst="roundRect">
+            <a:avLst/>
+          </a:prstGeom>
+          <a:solidFill>
+            <a:srgbClr val="1B2A4A"/>
+          </a:solidFill>
+          <a:ln w="15875">
+            <a:solidFill>
+              <a:srgbClr val="F2B14C"/>
+            </a:solidFill>
+          </a:ln>
+          <a:effectLst/>
+        </p:spPr>
+        <p:style>
+          <a:lnRef idx="1">
+            <a:schemeClr val="accent1"/>
+          </a:lnRef>
+          <a:fillRef idx="3">
+            <a:schemeClr val="accent1"/>
+          </a:fillRef>
+          <a:effectRef idx="2">
+            <a:schemeClr val="accent1"/>
+          </a:effectRef>
+          <a:fontRef idx="minor">
+            <a:schemeClr val="lt1"/>
+          </a:fontRef>
+        </p:style>
+        <p:txBody>
+          <a:bodyPr rtlCol="0" anchor="ctr" wrap="square" lIns="73152" rIns="73152" tIns="36576" bIns="36576"/>
+          <a:lstStyle/>
+          <a:p>
+            <a:pPr algn="l"/>
+            <a:r>
+              <a:rPr sz="1800" b="0">
+                <a:solidFill>
+                  <a:srgbClr val="F5F8FF"/>
+                </a:solidFill>
+                <a:latin typeface="Segoe UI"/>
+              </a:rPr>
+              <a:t>Phase 3 — Multi-party N:N with dynamic SDP renegotiation                 ✅ Verified</a:t>
+            </a:r>
+          </a:p>
+        </p:txBody>
+      </p:sp>
+      <p:sp>
+        <p:nvSpPr>
+          <p:cNvPr id="9" name="Rounded Rectangle 8"/>
+          <p:cNvSpPr/>
+          <p:nvPr/>
+        </p:nvSpPr>
+        <p:spPr>
+          <a:xfrm>
+            <a:off x="640080" y="4754880"/>
+            <a:ext cx="10881360" cy="1097280"/>
           </a:xfrm>
           <a:prstGeom prst="roundRect">
             <a:avLst/>
@@ -8398,14 +9198,14 @@
                 </a:solidFill>
                 <a:latin typeface="Segoe UI"/>
               </a:rPr>
-              <a:t>Two-way encrypted audio + video · keyframe relay · per-conference key rotation · unified config</a:t>
-            </a:r>
-          </a:p>
-        </p:txBody>
-      </p:sp>
-      <p:sp>
-        <p:nvSpPr>
-          <p:cNvPr id="9" name="TextBox 8"/>
+              <a:t>3-party encrypted audio + video · per-peer windows · keyframe relay · per-conference key rotation</a:t>
+            </a:r>
+          </a:p>
+        </p:txBody>
+      </p:sp>
+      <p:sp>
+        <p:nvSpPr>
+          <p:cNvPr id="10" name="TextBox 9"/>
           <p:cNvSpPr txBox="1"/>
           <p:nvPr/>
         </p:nvSpPr>
@@ -8440,7 +9240,7 @@
       </p:sp>
       <p:sp>
         <p:nvSpPr>
-          <p:cNvPr id="10" name="TextBox 9"/>
+          <p:cNvPr id="11" name="TextBox 10"/>
           <p:cNvSpPr txBox="1"/>
           <p:nvPr/>
         </p:nvSpPr>

</xml_diff>